<commit_message>
Build WPA submission artifacts
</commit_message>
<xml_diff>
--- a/WPA_Submission/slides/AI_to_ESP32_Unit3_Teaching_Slides_Mentimeter.pptx
+++ b/WPA_Submission/slides/AI_to_ESP32_Unit3_Teaching_Slides_Mentimeter.pptx
@@ -3400,20 +3400,31 @@
             </a:pPr>
             <a:r>
               <a:rPr/>
-              <a:t>เข้า: </a:t>
+              <a:t>เข้าโดยตรง: </a:t>
+            </a:r>
+            <a:r>
+              <a:rPr b="1">
+                <a:hlinkClick r:id="rId2"/>
+              </a:rPr>
+              <a:t>https://www.menti.com/alxdzgt83ktx</a:t>
+            </a:r>
+            <a:br/>
+            <a:r>
+              <a:rPr/>
+              <a:t>รหัส Menti ปัจจุบัน: </a:t>
             </a:r>
             <a:r>
               <a:rPr b="1"/>
-              <a:t>menti.com</a:t>
-            </a:r>
-            <a:br/>
-            <a:r>
-              <a:rPr/>
-              <a:t>รหัส: </a:t>
-            </a:r>
-            <a:r>
-              <a:rPr b="1"/>
-              <a:t>กรอกรหัสจริงที่ครูแสดงบนจอ</a:t>
+              <a:t>7812 2870</a:t>
+            </a:r>
+          </a:p>
+          <a:p>
+            <a:pPr lvl="0" indent="0" marL="1270000">
+              <a:buNone/>
+            </a:pPr>
+            <a:r>
+              <a:rPr sz="2000"/>
+              <a:t>สแกน QR_Mentimeter_Join.png ได้โดยตรง และควรตรวจรหัสอีกครั้งก่อนสอนจริง</a:t>
             </a:r>
           </a:p>
           <a:p>

</xml_diff>